<commit_message>
Include fonts for fidelity
</commit_message>
<xml_diff>
--- a/animation_test.pptx
+++ b/animation_test.pptx
@@ -1,6 +1,6 @@
 
 <file path=ppt/presentation.xml><?xml version="1.0" encoding="utf-8"?>
-<p:presentation xmlns:a="http://schemas.openxmlformats.org/drawingml/2006/main" xmlns:r="http://schemas.openxmlformats.org/officeDocument/2006/relationships" xmlns:p="http://schemas.openxmlformats.org/presentationml/2006/main" saveSubsetFonts="1" autoCompressPictures="0">
+<p:presentation xmlns:a="http://schemas.openxmlformats.org/drawingml/2006/main" xmlns:r="http://schemas.openxmlformats.org/officeDocument/2006/relationships" xmlns:p="http://schemas.openxmlformats.org/presentationml/2006/main" embedTrueTypeFonts="1" autoCompressPictures="0">
   <p:sldMasterIdLst>
     <p:sldMasterId id="2147483648" r:id="rId1"/>
   </p:sldMasterIdLst>
@@ -329,7 +329,7 @@
           <a:p>
             <a:fld id="{5BCAD085-E8A6-8845-BD4E-CB4CCA059FC4}" type="datetimeFigureOut">
               <a:rPr lang="en-US" smtClean="0"/>
-              <a:t>5/3/2026</a:t>
+              <a:t>10/14/2026</a:t>
             </a:fld>
             <a:endParaRPr lang="en-US"/>
           </a:p>
@@ -497,7 +497,7 @@
           <a:p>
             <a:fld id="{5BCAD085-E8A6-8845-BD4E-CB4CCA059FC4}" type="datetimeFigureOut">
               <a:rPr lang="en-US" smtClean="0"/>
-              <a:t>5/3/2026</a:t>
+              <a:t>10/14/2026</a:t>
             </a:fld>
             <a:endParaRPr lang="en-US"/>
           </a:p>
@@ -675,7 +675,7 @@
           <a:p>
             <a:fld id="{5BCAD085-E8A6-8845-BD4E-CB4CCA059FC4}" type="datetimeFigureOut">
               <a:rPr lang="en-US" smtClean="0"/>
-              <a:t>5/3/2026</a:t>
+              <a:t>10/14/2026</a:t>
             </a:fld>
             <a:endParaRPr lang="en-US"/>
           </a:p>
@@ -843,7 +843,7 @@
           <a:p>
             <a:fld id="{5BCAD085-E8A6-8845-BD4E-CB4CCA059FC4}" type="datetimeFigureOut">
               <a:rPr lang="en-US" smtClean="0"/>
-              <a:t>5/3/2026</a:t>
+              <a:t>10/14/2026</a:t>
             </a:fld>
             <a:endParaRPr lang="en-US"/>
           </a:p>
@@ -1088,7 +1088,7 @@
           <a:p>
             <a:fld id="{5BCAD085-E8A6-8845-BD4E-CB4CCA059FC4}" type="datetimeFigureOut">
               <a:rPr lang="en-US" smtClean="0"/>
-              <a:t>5/3/2026</a:t>
+              <a:t>10/14/2026</a:t>
             </a:fld>
             <a:endParaRPr lang="en-US"/>
           </a:p>
@@ -1373,7 +1373,7 @@
           <a:p>
             <a:fld id="{5BCAD085-E8A6-8845-BD4E-CB4CCA059FC4}" type="datetimeFigureOut">
               <a:rPr lang="en-US" smtClean="0"/>
-              <a:t>5/3/2026</a:t>
+              <a:t>10/14/2026</a:t>
             </a:fld>
             <a:endParaRPr lang="en-US"/>
           </a:p>
@@ -1792,7 +1792,7 @@
           <a:p>
             <a:fld id="{5BCAD085-E8A6-8845-BD4E-CB4CCA059FC4}" type="datetimeFigureOut">
               <a:rPr lang="en-US" smtClean="0"/>
-              <a:t>5/3/2026</a:t>
+              <a:t>10/14/2026</a:t>
             </a:fld>
             <a:endParaRPr lang="en-US"/>
           </a:p>
@@ -1909,7 +1909,7 @@
           <a:p>
             <a:fld id="{5BCAD085-E8A6-8845-BD4E-CB4CCA059FC4}" type="datetimeFigureOut">
               <a:rPr lang="en-US" smtClean="0"/>
-              <a:t>5/3/2026</a:t>
+              <a:t>10/14/2026</a:t>
             </a:fld>
             <a:endParaRPr lang="en-US"/>
           </a:p>
@@ -2004,7 +2004,7 @@
           <a:p>
             <a:fld id="{5BCAD085-E8A6-8845-BD4E-CB4CCA059FC4}" type="datetimeFigureOut">
               <a:rPr lang="en-US" smtClean="0"/>
-              <a:t>5/3/2026</a:t>
+              <a:t>10/14/2026</a:t>
             </a:fld>
             <a:endParaRPr lang="en-US"/>
           </a:p>
@@ -2279,7 +2279,7 @@
           <a:p>
             <a:fld id="{5BCAD085-E8A6-8845-BD4E-CB4CCA059FC4}" type="datetimeFigureOut">
               <a:rPr lang="en-US" smtClean="0"/>
-              <a:t>5/3/2026</a:t>
+              <a:t>10/14/2026</a:t>
             </a:fld>
             <a:endParaRPr lang="en-US"/>
           </a:p>
@@ -2531,7 +2531,7 @@
           <a:p>
             <a:fld id="{5BCAD085-E8A6-8845-BD4E-CB4CCA059FC4}" type="datetimeFigureOut">
               <a:rPr lang="en-US" smtClean="0"/>
-              <a:t>5/3/2026</a:t>
+              <a:t>10/14/2026</a:t>
             </a:fld>
             <a:endParaRPr lang="en-US"/>
           </a:p>
@@ -2742,7 +2742,7 @@
           <a:p>
             <a:fld id="{5BCAD085-E8A6-8845-BD4E-CB4CCA059FC4}" type="datetimeFigureOut">
               <a:rPr lang="en-US" smtClean="0"/>
-              <a:t>5/3/2026</a:t>
+              <a:t>10/14/2026</a:t>
             </a:fld>
             <a:endParaRPr lang="en-US"/>
           </a:p>

</xml_diff>